<commit_message>
fix: manual com logo LAWgico corrigido
</commit_message>
<xml_diff>
--- a/PromptInject/LAWgico_PromptInject_Manual.pptx
+++ b/PromptInject/LAWgico_PromptInject_Manual.pptx
@@ -3276,8 +3276,8 @@
         </p:nvSpPr>
         <p:spPr>
           <a:xfrm>
-            <a:off x="540000" y="1260000"/>
-            <a:ext cx="2880000" cy="1260000"/>
+            <a:off x="540000" y="1440000"/>
+            <a:ext cx="7920000" cy="1260000"/>
           </a:xfrm>
           <a:prstGeom prst="rect">
             <a:avLst/>
@@ -3298,7 +3298,7 @@
                 </a:solidFill>
                 <a:latin typeface="Calibri"/>
               </a:rPr>
-              <a:t>LAW</a:t>
+              <a:t>LAWgico</a:t>
             </a:r>
           </a:p>
         </p:txBody>
@@ -3311,8 +3311,8 @@
         </p:nvSpPr>
         <p:spPr>
           <a:xfrm>
-            <a:off x="2448000" y="1260000"/>
-            <a:ext cx="2880000" cy="1260000"/>
+            <a:off x="2988000" y="1152000"/>
+            <a:ext cx="3600000" cy="324000"/>
           </a:xfrm>
           <a:prstGeom prst="rect">
             <a:avLst/>
@@ -3327,13 +3327,13 @@
           <a:p>
             <a:pPr algn="l"/>
             <a:r>
-              <a:rPr sz="7200" b="1" i="0">
-                <a:solidFill>
-                  <a:srgbClr val="FFFFFF"/>
-                </a:solidFill>
-                <a:latin typeface="Calibri"/>
-              </a:rPr>
-              <a:t>gico</a:t>
+              <a:rPr sz="1300" b="1" i="0">
+                <a:solidFill>
+                  <a:srgbClr val="00A9E0"/>
+                </a:solidFill>
+                <a:latin typeface="Calibri"/>
+              </a:rPr>
+              <a:t>prompt inject</a:t>
             </a:r>
           </a:p>
         </p:txBody>
@@ -3346,8 +3346,8 @@
         </p:nvSpPr>
         <p:spPr>
           <a:xfrm>
-            <a:off x="2448000" y="1188000"/>
-            <a:ext cx="2880000" cy="360000"/>
+            <a:off x="540000" y="2951999"/>
+            <a:ext cx="7200000" cy="540000"/>
           </a:xfrm>
           <a:prstGeom prst="rect">
             <a:avLst/>
@@ -3362,13 +3362,13 @@
           <a:p>
             <a:pPr algn="l"/>
             <a:r>
-              <a:rPr sz="1400" b="1" i="0">
-                <a:solidFill>
-                  <a:srgbClr val="00A9E0"/>
-                </a:solidFill>
-                <a:latin typeface="Calibri"/>
-              </a:rPr>
-              <a:t>prompt inject</a:t>
+              <a:rPr sz="2400" b="1" i="0">
+                <a:solidFill>
+                  <a:srgbClr val="FFFFFF"/>
+                </a:solidFill>
+                <a:latin typeface="Calibri"/>
+              </a:rPr>
+              <a:t>Manual do Usuário</a:t>
             </a:r>
           </a:p>
         </p:txBody>
@@ -3381,8 +3381,8 @@
         </p:nvSpPr>
         <p:spPr>
           <a:xfrm>
-            <a:off x="540000" y="2951999"/>
-            <a:ext cx="7200000" cy="540000"/>
+            <a:off x="540000" y="3528000"/>
+            <a:ext cx="8640000" cy="540000"/>
           </a:xfrm>
           <a:prstGeom prst="rect">
             <a:avLst/>
@@ -3397,13 +3397,13 @@
           <a:p>
             <a:pPr algn="l"/>
             <a:r>
-              <a:rPr sz="2400" b="1" i="0">
-                <a:solidFill>
-                  <a:srgbClr val="FFFFFF"/>
-                </a:solidFill>
-                <a:latin typeface="Calibri"/>
-              </a:rPr>
-              <a:t>Manual do Usuário</a:t>
+              <a:rPr sz="1400" b="0" i="0">
+                <a:solidFill>
+                  <a:srgbClr val="90C8E0"/>
+                </a:solidFill>
+                <a:latin typeface="Calibri"/>
+              </a:rPr>
+              <a:t>Detecção de Prompt Injection e Análise de Risco Jurídico em Peças Processuais</a:t>
             </a:r>
           </a:p>
         </p:txBody>
@@ -3416,8 +3416,8 @@
         </p:nvSpPr>
         <p:spPr>
           <a:xfrm>
-            <a:off x="540000" y="3528000"/>
-            <a:ext cx="8640000" cy="540000"/>
+            <a:off x="540000" y="4140000"/>
+            <a:ext cx="8640000" cy="360000"/>
           </a:xfrm>
           <a:prstGeom prst="rect">
             <a:avLst/>
@@ -3432,41 +3432,6 @@
           <a:p>
             <a:pPr algn="l"/>
             <a:r>
-              <a:rPr sz="1400" b="0" i="0">
-                <a:solidFill>
-                  <a:srgbClr val="90C8E0"/>
-                </a:solidFill>
-                <a:latin typeface="Calibri"/>
-              </a:rPr>
-              <a:t>Detecção de Prompt Injection e Análise de Risco Jurídico em Peças Processuais</a:t>
-            </a:r>
-          </a:p>
-        </p:txBody>
-      </p:sp>
-      <p:sp>
-        <p:nvSpPr>
-          <p:cNvPr id="11" name="TextBox 10"/>
-          <p:cNvSpPr txBox="1"/>
-          <p:nvPr/>
-        </p:nvSpPr>
-        <p:spPr>
-          <a:xfrm>
-            <a:off x="540000" y="4140000"/>
-            <a:ext cx="8640000" cy="360000"/>
-          </a:xfrm>
-          <a:prstGeom prst="rect">
-            <a:avLst/>
-          </a:prstGeom>
-          <a:noFill/>
-        </p:spPr>
-        <p:txBody>
-          <a:bodyPr wrap="square">
-            <a:spAutoFit/>
-          </a:bodyPr>
-          <a:lstStyle/>
-          <a:p>
-            <a:pPr algn="l"/>
-            <a:r>
               <a:rPr sz="1100" b="0" i="1">
                 <a:solidFill>
                   <a:srgbClr val="6B7F93"/>
@@ -3480,7 +3445,7 @@
       </p:sp>
       <p:sp>
         <p:nvSpPr>
-          <p:cNvPr id="12" name="Rectangle 11"/>
+          <p:cNvPr id="11" name="Rectangle 10"/>
           <p:cNvSpPr/>
           <p:nvPr/>
         </p:nvSpPr>
@@ -3523,7 +3488,7 @@
       </p:sp>
       <p:sp>
         <p:nvSpPr>
-          <p:cNvPr id="13" name="TextBox 12"/>
+          <p:cNvPr id="12" name="TextBox 11"/>
           <p:cNvSpPr txBox="1"/>
           <p:nvPr/>
         </p:nvSpPr>
@@ -3558,7 +3523,7 @@
       </p:sp>
       <p:sp>
         <p:nvSpPr>
-          <p:cNvPr id="14" name="Rectangle 13"/>
+          <p:cNvPr id="13" name="Rectangle 12"/>
           <p:cNvSpPr/>
           <p:nvPr/>
         </p:nvSpPr>
@@ -3601,7 +3566,7 @@
       </p:sp>
       <p:sp>
         <p:nvSpPr>
-          <p:cNvPr id="15" name="TextBox 14"/>
+          <p:cNvPr id="14" name="TextBox 13"/>
           <p:cNvSpPr txBox="1"/>
           <p:nvPr/>
         </p:nvSpPr>
@@ -3636,7 +3601,7 @@
       </p:sp>
       <p:sp>
         <p:nvSpPr>
-          <p:cNvPr id="16" name="Rectangle 15"/>
+          <p:cNvPr id="15" name="Rectangle 14"/>
           <p:cNvSpPr/>
           <p:nvPr/>
         </p:nvSpPr>
@@ -3679,7 +3644,7 @@
       </p:sp>
       <p:sp>
         <p:nvSpPr>
-          <p:cNvPr id="17" name="TextBox 16"/>
+          <p:cNvPr id="16" name="TextBox 15"/>
           <p:cNvSpPr txBox="1"/>
           <p:nvPr/>
         </p:nvSpPr>
@@ -10774,8 +10739,8 @@
         </p:nvSpPr>
         <p:spPr>
           <a:xfrm>
-            <a:off x="540000" y="1260000"/>
-            <a:ext cx="2880000" cy="1260000"/>
+            <a:off x="540000" y="1440000"/>
+            <a:ext cx="7920000" cy="1260000"/>
           </a:xfrm>
           <a:prstGeom prst="rect">
             <a:avLst/>
@@ -10796,7 +10761,7 @@
                 </a:solidFill>
                 <a:latin typeface="Calibri"/>
               </a:rPr>
-              <a:t>LAW</a:t>
+              <a:t>LAWgico</a:t>
             </a:r>
           </a:p>
         </p:txBody>
@@ -10809,8 +10774,8 @@
         </p:nvSpPr>
         <p:spPr>
           <a:xfrm>
-            <a:off x="2448000" y="1260000"/>
-            <a:ext cx="2880000" cy="1260000"/>
+            <a:off x="2988000" y="1152000"/>
+            <a:ext cx="3600000" cy="324000"/>
           </a:xfrm>
           <a:prstGeom prst="rect">
             <a:avLst/>
@@ -10825,13 +10790,13 @@
           <a:p>
             <a:pPr algn="l"/>
             <a:r>
-              <a:rPr sz="7200" b="1" i="0">
-                <a:solidFill>
-                  <a:srgbClr val="FFFFFF"/>
-                </a:solidFill>
-                <a:latin typeface="Calibri"/>
-              </a:rPr>
-              <a:t>gico</a:t>
+              <a:rPr sz="1300" b="1" i="0">
+                <a:solidFill>
+                  <a:srgbClr val="00A9E0"/>
+                </a:solidFill>
+                <a:latin typeface="Calibri"/>
+              </a:rPr>
+              <a:t>prompt inject</a:t>
             </a:r>
           </a:p>
         </p:txBody>
@@ -10844,8 +10809,8 @@
         </p:nvSpPr>
         <p:spPr>
           <a:xfrm>
-            <a:off x="2448000" y="1188000"/>
-            <a:ext cx="2880000" cy="360000"/>
+            <a:off x="540000" y="3240000"/>
+            <a:ext cx="9000000" cy="540000"/>
           </a:xfrm>
           <a:prstGeom prst="rect">
             <a:avLst/>
@@ -10860,13 +10825,13 @@
           <a:p>
             <a:pPr algn="l"/>
             <a:r>
-              <a:rPr sz="1400" b="1" i="0">
-                <a:solidFill>
-                  <a:srgbClr val="00A9E0"/>
-                </a:solidFill>
-                <a:latin typeface="Calibri"/>
-              </a:rPr>
-              <a:t>prompt inject</a:t>
+              <a:rPr sz="1800" b="0" i="0">
+                <a:solidFill>
+                  <a:srgbClr val="FFFFFF"/>
+                </a:solidFill>
+                <a:latin typeface="Calibri"/>
+              </a:rPr>
+              <a:t>Dúvidas? Fale com a Controladoria.</a:t>
             </a:r>
           </a:p>
         </p:txBody>
@@ -10879,8 +10844,8 @@
         </p:nvSpPr>
         <p:spPr>
           <a:xfrm>
-            <a:off x="540000" y="3240000"/>
-            <a:ext cx="9000000" cy="540000"/>
+            <a:off x="540000" y="3888000"/>
+            <a:ext cx="9000000" cy="360000"/>
           </a:xfrm>
           <a:prstGeom prst="rect">
             <a:avLst/>
@@ -10895,13 +10860,13 @@
           <a:p>
             <a:pPr algn="l"/>
             <a:r>
-              <a:rPr sz="1800" b="0" i="0">
-                <a:solidFill>
-                  <a:srgbClr val="FFFFFF"/>
-                </a:solidFill>
-                <a:latin typeface="Calibri"/>
-              </a:rPr>
-              <a:t>Dúvidas? Fale com a Controladoria.</a:t>
+              <a:rPr sz="1400" b="0" i="0">
+                <a:solidFill>
+                  <a:srgbClr val="00A9E0"/>
+                </a:solidFill>
+                <a:latin typeface="Calibri"/>
+              </a:rPr>
+              <a:t>lawgico-prompt-inject.streamlit.app</a:t>
             </a:r>
           </a:p>
         </p:txBody>
@@ -10909,41 +10874,6 @@
       <p:sp>
         <p:nvSpPr>
           <p:cNvPr id="10" name="TextBox 9"/>
-          <p:cNvSpPr txBox="1"/>
-          <p:nvPr/>
-        </p:nvSpPr>
-        <p:spPr>
-          <a:xfrm>
-            <a:off x="540000" y="3888000"/>
-            <a:ext cx="9000000" cy="360000"/>
-          </a:xfrm>
-          <a:prstGeom prst="rect">
-            <a:avLst/>
-          </a:prstGeom>
-          <a:noFill/>
-        </p:spPr>
-        <p:txBody>
-          <a:bodyPr wrap="square">
-            <a:spAutoFit/>
-          </a:bodyPr>
-          <a:lstStyle/>
-          <a:p>
-            <a:pPr algn="l"/>
-            <a:r>
-              <a:rPr sz="1400" b="0" i="0">
-                <a:solidFill>
-                  <a:srgbClr val="00A9E0"/>
-                </a:solidFill>
-                <a:latin typeface="Calibri"/>
-              </a:rPr>
-              <a:t>lawgico-prompt-inject.streamlit.app</a:t>
-            </a:r>
-          </a:p>
-        </p:txBody>
-      </p:sp>
-      <p:sp>
-        <p:nvSpPr>
-          <p:cNvPr id="11" name="TextBox 10"/>
           <p:cNvSpPr txBox="1"/>
           <p:nvPr/>
         </p:nvSpPr>

</xml_diff>